<commit_message>
fix case study 1
</commit_message>
<xml_diff>
--- a/figures_tables/Supplemental_Figures/Supp_Figures.pptx
+++ b/figures_tables/Supplemental_Figures/Supp_Figures.pptx
@@ -3099,12 +3099,152 @@
           </a:prstGeom>
         </p:spPr>
       </p:pic>
+      <p:sp>
+        <p:nvSpPr>
+          <p:cNvPr id="8" name="TextBox 7">
+            <a:extLst>
+              <a:ext uri="{FF2B5EF4-FFF2-40B4-BE49-F238E27FC236}">
+                <a16:creationId xmlns:a16="http://schemas.microsoft.com/office/drawing/2014/main" id="{91841A04-5509-56EB-0B34-5214B10A559E}"/>
+              </a:ext>
+            </a:extLst>
+          </p:cNvPr>
+          <p:cNvSpPr txBox="1"/>
+          <p:nvPr/>
+        </p:nvSpPr>
+        <p:spPr>
+          <a:xfrm>
+            <a:off x="0" y="0"/>
+            <a:ext cx="372628" cy="307777"/>
+          </a:xfrm>
+          <a:prstGeom prst="rect">
+            <a:avLst/>
+          </a:prstGeom>
+          <a:noFill/>
+        </p:spPr>
+        <p:txBody>
+          <a:bodyPr wrap="square" rtlCol="0">
+            <a:spAutoFit/>
+          </a:bodyPr>
+          <a:lstStyle/>
+          <a:p>
+            <a:r>
+              <a:rPr lang="en-US" sz="1400" b="1" dirty="0"/>
+              <a:t>a</a:t>
+            </a:r>
+          </a:p>
+        </p:txBody>
+      </p:sp>
+      <p:sp>
+        <p:nvSpPr>
+          <p:cNvPr id="9" name="TextBox 8">
+            <a:extLst>
+              <a:ext uri="{FF2B5EF4-FFF2-40B4-BE49-F238E27FC236}">
+                <a16:creationId xmlns:a16="http://schemas.microsoft.com/office/drawing/2014/main" id="{1920FFFD-FB21-512D-0CA0-EE5F1580C688}"/>
+              </a:ext>
+            </a:extLst>
+          </p:cNvPr>
+          <p:cNvSpPr txBox="1"/>
+          <p:nvPr/>
+        </p:nvSpPr>
+        <p:spPr>
+          <a:xfrm>
+            <a:off x="0" y="1891562"/>
+            <a:ext cx="372628" cy="307777"/>
+          </a:xfrm>
+          <a:prstGeom prst="rect">
+            <a:avLst/>
+          </a:prstGeom>
+          <a:noFill/>
+        </p:spPr>
+        <p:txBody>
+          <a:bodyPr wrap="square" rtlCol="0">
+            <a:spAutoFit/>
+          </a:bodyPr>
+          <a:lstStyle/>
+          <a:p>
+            <a:r>
+              <a:rPr lang="en-US" sz="1400" b="1" dirty="0"/>
+              <a:t>b</a:t>
+            </a:r>
+          </a:p>
+        </p:txBody>
+      </p:sp>
+      <p:sp>
+        <p:nvSpPr>
+          <p:cNvPr id="10" name="TextBox 9">
+            <a:extLst>
+              <a:ext uri="{FF2B5EF4-FFF2-40B4-BE49-F238E27FC236}">
+                <a16:creationId xmlns:a16="http://schemas.microsoft.com/office/drawing/2014/main" id="{BC6CF565-2466-C70C-0132-AFB00E6092C5}"/>
+              </a:ext>
+            </a:extLst>
+          </p:cNvPr>
+          <p:cNvSpPr txBox="1"/>
+          <p:nvPr/>
+        </p:nvSpPr>
+        <p:spPr>
+          <a:xfrm>
+            <a:off x="0" y="5400183"/>
+            <a:ext cx="372628" cy="307777"/>
+          </a:xfrm>
+          <a:prstGeom prst="rect">
+            <a:avLst/>
+          </a:prstGeom>
+          <a:noFill/>
+        </p:spPr>
+        <p:txBody>
+          <a:bodyPr wrap="square" rtlCol="0">
+            <a:spAutoFit/>
+          </a:bodyPr>
+          <a:lstStyle/>
+          <a:p>
+            <a:r>
+              <a:rPr lang="en-US" sz="1400" b="1" dirty="0"/>
+              <a:t>c</a:t>
+            </a:r>
+          </a:p>
+        </p:txBody>
+      </p:sp>
+      <p:sp>
+        <p:nvSpPr>
+          <p:cNvPr id="11" name="TextBox 10">
+            <a:extLst>
+              <a:ext uri="{FF2B5EF4-FFF2-40B4-BE49-F238E27FC236}">
+                <a16:creationId xmlns:a16="http://schemas.microsoft.com/office/drawing/2014/main" id="{BFE5FE02-2E92-B04F-D9A3-5C5205DEA6AC}"/>
+              </a:ext>
+            </a:extLst>
+          </p:cNvPr>
+          <p:cNvSpPr txBox="1"/>
+          <p:nvPr/>
+        </p:nvSpPr>
+        <p:spPr>
+          <a:xfrm>
+            <a:off x="0" y="7280346"/>
+            <a:ext cx="372628" cy="307777"/>
+          </a:xfrm>
+          <a:prstGeom prst="rect">
+            <a:avLst/>
+          </a:prstGeom>
+          <a:noFill/>
+        </p:spPr>
+        <p:txBody>
+          <a:bodyPr wrap="square" rtlCol="0">
+            <a:spAutoFit/>
+          </a:bodyPr>
+          <a:lstStyle/>
+          <a:p>
+            <a:r>
+              <a:rPr lang="en-US" sz="1400" b="1" dirty="0"/>
+              <a:t>d</a:t>
+            </a:r>
+          </a:p>
+        </p:txBody>
+      </p:sp>
       <p:pic>
         <p:nvPicPr>
-          <p:cNvPr id="6" name="Picture 5">
+          <p:cNvPr id="13" name="Picture 12">
             <a:extLst>
               <a:ext uri="{FF2B5EF4-FFF2-40B4-BE49-F238E27FC236}">
-                <a16:creationId xmlns:a16="http://schemas.microsoft.com/office/drawing/2014/main" id="{3A66B98A-7A3A-8268-2208-83127BC91A48}"/>
+                <a16:creationId xmlns:a16="http://schemas.microsoft.com/office/drawing/2014/main" id="{7C184FD6-0D22-A3B7-1BC6-E85DA4F2A2C1}"/>
               </a:ext>
             </a:extLst>
           </p:cNvPr>
@@ -3121,8 +3261,8 @@
         </p:blipFill>
         <p:spPr>
           <a:xfrm>
-            <a:off x="372627" y="5480527"/>
-            <a:ext cx="3850061" cy="1509946"/>
+            <a:off x="372627" y="5601764"/>
+            <a:ext cx="3850062" cy="1509946"/>
           </a:xfrm>
           <a:prstGeom prst="rect">
             <a:avLst/>
@@ -3131,10 +3271,10 @@
       </p:pic>
       <p:pic>
         <p:nvPicPr>
-          <p:cNvPr id="7" name="Picture 6">
+          <p:cNvPr id="15" name="Picture 14">
             <a:extLst>
               <a:ext uri="{FF2B5EF4-FFF2-40B4-BE49-F238E27FC236}">
-                <a16:creationId xmlns:a16="http://schemas.microsoft.com/office/drawing/2014/main" id="{BAE405FE-4FC0-CBD8-10D3-275179A7771C}"/>
+                <a16:creationId xmlns:a16="http://schemas.microsoft.com/office/drawing/2014/main" id="{AC8D836A-172E-B056-D84F-EB0440CA122A}"/>
               </a:ext>
             </a:extLst>
           </p:cNvPr>
@@ -3151,7 +3291,7 @@
         </p:blipFill>
         <p:spPr>
           <a:xfrm>
-            <a:off x="269485" y="7495711"/>
+            <a:off x="282011" y="7588123"/>
             <a:ext cx="3850062" cy="1509946"/>
           </a:xfrm>
           <a:prstGeom prst="rect">
@@ -3159,146 +3299,6 @@
           </a:prstGeom>
         </p:spPr>
       </p:pic>
-      <p:sp>
-        <p:nvSpPr>
-          <p:cNvPr id="8" name="TextBox 7">
-            <a:extLst>
-              <a:ext uri="{FF2B5EF4-FFF2-40B4-BE49-F238E27FC236}">
-                <a16:creationId xmlns:a16="http://schemas.microsoft.com/office/drawing/2014/main" id="{91841A04-5509-56EB-0B34-5214B10A559E}"/>
-              </a:ext>
-            </a:extLst>
-          </p:cNvPr>
-          <p:cNvSpPr txBox="1"/>
-          <p:nvPr/>
-        </p:nvSpPr>
-        <p:spPr>
-          <a:xfrm>
-            <a:off x="0" y="0"/>
-            <a:ext cx="372628" cy="307777"/>
-          </a:xfrm>
-          <a:prstGeom prst="rect">
-            <a:avLst/>
-          </a:prstGeom>
-          <a:noFill/>
-        </p:spPr>
-        <p:txBody>
-          <a:bodyPr wrap="square" rtlCol="0">
-            <a:spAutoFit/>
-          </a:bodyPr>
-          <a:lstStyle/>
-          <a:p>
-            <a:r>
-              <a:rPr lang="en-US" sz="1400" b="1" dirty="0"/>
-              <a:t>a</a:t>
-            </a:r>
-          </a:p>
-        </p:txBody>
-      </p:sp>
-      <p:sp>
-        <p:nvSpPr>
-          <p:cNvPr id="9" name="TextBox 8">
-            <a:extLst>
-              <a:ext uri="{FF2B5EF4-FFF2-40B4-BE49-F238E27FC236}">
-                <a16:creationId xmlns:a16="http://schemas.microsoft.com/office/drawing/2014/main" id="{1920FFFD-FB21-512D-0CA0-EE5F1580C688}"/>
-              </a:ext>
-            </a:extLst>
-          </p:cNvPr>
-          <p:cNvSpPr txBox="1"/>
-          <p:nvPr/>
-        </p:nvSpPr>
-        <p:spPr>
-          <a:xfrm>
-            <a:off x="0" y="1891562"/>
-            <a:ext cx="372628" cy="307777"/>
-          </a:xfrm>
-          <a:prstGeom prst="rect">
-            <a:avLst/>
-          </a:prstGeom>
-          <a:noFill/>
-        </p:spPr>
-        <p:txBody>
-          <a:bodyPr wrap="square" rtlCol="0">
-            <a:spAutoFit/>
-          </a:bodyPr>
-          <a:lstStyle/>
-          <a:p>
-            <a:r>
-              <a:rPr lang="en-US" sz="1400" b="1" dirty="0"/>
-              <a:t>b</a:t>
-            </a:r>
-          </a:p>
-        </p:txBody>
-      </p:sp>
-      <p:sp>
-        <p:nvSpPr>
-          <p:cNvPr id="10" name="TextBox 9">
-            <a:extLst>
-              <a:ext uri="{FF2B5EF4-FFF2-40B4-BE49-F238E27FC236}">
-                <a16:creationId xmlns:a16="http://schemas.microsoft.com/office/drawing/2014/main" id="{BC6CF565-2466-C70C-0132-AFB00E6092C5}"/>
-              </a:ext>
-            </a:extLst>
-          </p:cNvPr>
-          <p:cNvSpPr txBox="1"/>
-          <p:nvPr/>
-        </p:nvSpPr>
-        <p:spPr>
-          <a:xfrm>
-            <a:off x="0" y="5400183"/>
-            <a:ext cx="372628" cy="307777"/>
-          </a:xfrm>
-          <a:prstGeom prst="rect">
-            <a:avLst/>
-          </a:prstGeom>
-          <a:noFill/>
-        </p:spPr>
-        <p:txBody>
-          <a:bodyPr wrap="square" rtlCol="0">
-            <a:spAutoFit/>
-          </a:bodyPr>
-          <a:lstStyle/>
-          <a:p>
-            <a:r>
-              <a:rPr lang="en-US" sz="1400" b="1" dirty="0"/>
-              <a:t>c</a:t>
-            </a:r>
-          </a:p>
-        </p:txBody>
-      </p:sp>
-      <p:sp>
-        <p:nvSpPr>
-          <p:cNvPr id="11" name="TextBox 10">
-            <a:extLst>
-              <a:ext uri="{FF2B5EF4-FFF2-40B4-BE49-F238E27FC236}">
-                <a16:creationId xmlns:a16="http://schemas.microsoft.com/office/drawing/2014/main" id="{BFE5FE02-2E92-B04F-D9A3-5C5205DEA6AC}"/>
-              </a:ext>
-            </a:extLst>
-          </p:cNvPr>
-          <p:cNvSpPr txBox="1"/>
-          <p:nvPr/>
-        </p:nvSpPr>
-        <p:spPr>
-          <a:xfrm>
-            <a:off x="0" y="7280346"/>
-            <a:ext cx="372628" cy="307777"/>
-          </a:xfrm>
-          <a:prstGeom prst="rect">
-            <a:avLst/>
-          </a:prstGeom>
-          <a:noFill/>
-        </p:spPr>
-        <p:txBody>
-          <a:bodyPr wrap="square" rtlCol="0">
-            <a:spAutoFit/>
-          </a:bodyPr>
-          <a:lstStyle/>
-          <a:p>
-            <a:r>
-              <a:rPr lang="en-US" sz="1400" b="1" dirty="0"/>
-              <a:t>d</a:t>
-            </a:r>
-          </a:p>
-        </p:txBody>
-      </p:sp>
     </p:spTree>
     <p:extLst>
       <p:ext uri="{BB962C8B-B14F-4D97-AF65-F5344CB8AC3E}">
@@ -6113,13 +6113,8 @@
             </a:r>
             <a:r>
               <a:rPr lang="en-CA" sz="1100" dirty="0"/>
-              <a:t> transcriptome). Positive NES: enriched in Sensitive models; negative NES: enriched in </a:t>
-            </a:r>
-            <a:r>
-              <a:rPr lang="en-CA" sz="1100"/>
-              <a:t>Resistant models (FDR q &lt; 0.05) .</a:t>
-            </a:r>
-            <a:endParaRPr lang="en-CA" sz="1100" dirty="0"/>
+              <a:t> transcriptome). Positive NES: enriched in Sensitive models; negative NES: enriched in Resistant models (FDR q &lt; 0.05) .</a:t>
+            </a:r>
           </a:p>
         </p:txBody>
       </p:sp>

</xml_diff>